<commit_message>
Access thumbnail: add mini table graphic
Co-Authored-By: Claude Sonnet 5.5 <noreply@anthropic.com>
Claude-Session: https://claude.ai/code/session_0139kriXJ67p3UvpR2gsSR9G
</commit_message>
<xml_diff>
--- a/videoslides/cleverbox-thumbnail-anlegen.pptx
+++ b/videoslides/cleverbox-thumbnail-anlegen.pptx
@@ -1423,6 +1423,582 @@
             <a:prstDash val="solid"/>
           </a:ln>
         </p:spPr>
+      </p:sp>
+      <p:sp>
+        <p:nvSpPr>
+          <p:cNvPr id="21" name="Tabelle Zelle 1"/>
+          <p:cNvSpPr/>
+          <p:nvPr/>
+        </p:nvSpPr>
+        <p:spPr>
+          <a:xfrm>
+            <a:off x="9029700" y="323850"/>
+            <a:ext cx="742950" cy="361950"/>
+          </a:xfrm>
+          <a:prstGeom prst="rect">
+            <a:avLst/>
+          </a:prstGeom>
+          <a:solidFill>
+            <a:srgbClr val="12301A"/>
+          </a:solidFill>
+          <a:ln w="19050">
+            <a:solidFill>
+              <a:srgbClr val="B8D98A"/>
+            </a:solidFill>
+            <a:prstDash val="solid"/>
+          </a:ln>
+        </p:spPr>
+      </p:sp>
+      <p:sp>
+        <p:nvSpPr>
+          <p:cNvPr id="22" name="Tabelle Text 1"/>
+          <p:cNvSpPr txBox="1"/>
+          <p:nvPr/>
+        </p:nvSpPr>
+        <p:spPr>
+          <a:xfrm>
+            <a:off x="9029700" y="323850"/>
+            <a:ext cx="742950" cy="361950"/>
+          </a:xfrm>
+          <a:prstGeom prst="rect">
+            <a:avLst/>
+          </a:prstGeom>
+          <a:noFill/>
+          <a:ln/>
+        </p:spPr>
+        <p:txBody>
+          <a:bodyPr wrap="square" lIns="0" tIns="0" rIns="0" bIns="0" rtlCol="0" anchor="ctr"/>
+          <a:lstStyle/>
+          <a:p>
+            <a:pPr algn="ctr" indent="0" marL="0">
+              <a:buNone/>
+            </a:pPr>
+            <a:r>
+              <a:rPr lang="en-US" sz="1300" b="1" dirty="0">
+                <a:solidFill>
+                  <a:srgbClr val="B1FF37"/>
+                </a:solidFill>
+                <a:latin typeface="Poppins" pitchFamily="34" charset="0"/>
+                <a:ea typeface="Poppins" pitchFamily="34" charset="-122"/>
+                <a:cs typeface="Poppins" pitchFamily="34" charset="-120"/>
+              </a:rPr>
+              <a:t>ID</a:t>
+            </a:r>
+            <a:endParaRPr lang="en-US" sz="1300" dirty="0"/>
+          </a:p>
+        </p:txBody>
+      </p:sp>
+      <p:sp>
+        <p:nvSpPr>
+          <p:cNvPr id="23" name="Tabelle Zelle 2"/>
+          <p:cNvSpPr/>
+          <p:nvPr/>
+        </p:nvSpPr>
+        <p:spPr>
+          <a:xfrm>
+            <a:off x="9772650" y="323850"/>
+            <a:ext cx="1066800" cy="361950"/>
+          </a:xfrm>
+          <a:prstGeom prst="rect">
+            <a:avLst/>
+          </a:prstGeom>
+          <a:solidFill>
+            <a:srgbClr val="12301A"/>
+          </a:solidFill>
+          <a:ln w="19050">
+            <a:solidFill>
+              <a:srgbClr val="B8D98A"/>
+            </a:solidFill>
+            <a:prstDash val="solid"/>
+          </a:ln>
+        </p:spPr>
+      </p:sp>
+      <p:sp>
+        <p:nvSpPr>
+          <p:cNvPr id="24" name="Tabelle Text 2"/>
+          <p:cNvSpPr txBox="1"/>
+          <p:nvPr/>
+        </p:nvSpPr>
+        <p:spPr>
+          <a:xfrm>
+            <a:off x="9772650" y="323850"/>
+            <a:ext cx="1066800" cy="361950"/>
+          </a:xfrm>
+          <a:prstGeom prst="rect">
+            <a:avLst/>
+          </a:prstGeom>
+          <a:noFill/>
+          <a:ln/>
+        </p:spPr>
+        <p:txBody>
+          <a:bodyPr wrap="square" lIns="0" tIns="0" rIns="0" bIns="0" rtlCol="0" anchor="ctr"/>
+          <a:lstStyle/>
+          <a:p>
+            <a:pPr algn="ctr" indent="0" marL="0">
+              <a:buNone/>
+            </a:pPr>
+            <a:r>
+              <a:rPr lang="en-US" sz="1300" b="1" dirty="0">
+                <a:solidFill>
+                  <a:srgbClr val="B1FF37"/>
+                </a:solidFill>
+                <a:latin typeface="Poppins" pitchFamily="34" charset="0"/>
+                <a:ea typeface="Poppins" pitchFamily="34" charset="-122"/>
+                <a:cs typeface="Poppins" pitchFamily="34" charset="-120"/>
+              </a:rPr>
+              <a:t>Titel</a:t>
+            </a:r>
+            <a:endParaRPr lang="en-US" sz="1300" dirty="0"/>
+          </a:p>
+        </p:txBody>
+      </p:sp>
+      <p:sp>
+        <p:nvSpPr>
+          <p:cNvPr id="25" name="Tabelle Zelle 3"/>
+          <p:cNvSpPr/>
+          <p:nvPr/>
+        </p:nvSpPr>
+        <p:spPr>
+          <a:xfrm>
+            <a:off x="10839450" y="323850"/>
+            <a:ext cx="1066800" cy="361950"/>
+          </a:xfrm>
+          <a:prstGeom prst="rect">
+            <a:avLst/>
+          </a:prstGeom>
+          <a:solidFill>
+            <a:srgbClr val="12301A"/>
+          </a:solidFill>
+          <a:ln w="19050">
+            <a:solidFill>
+              <a:srgbClr val="B8D98A"/>
+            </a:solidFill>
+            <a:prstDash val="solid"/>
+          </a:ln>
+        </p:spPr>
+      </p:sp>
+      <p:sp>
+        <p:nvSpPr>
+          <p:cNvPr id="26" name="Tabelle Text 3"/>
+          <p:cNvSpPr txBox="1"/>
+          <p:nvPr/>
+        </p:nvSpPr>
+        <p:spPr>
+          <a:xfrm>
+            <a:off x="10839450" y="323850"/>
+            <a:ext cx="1066800" cy="361950"/>
+          </a:xfrm>
+          <a:prstGeom prst="rect">
+            <a:avLst/>
+          </a:prstGeom>
+          <a:noFill/>
+          <a:ln/>
+        </p:spPr>
+        <p:txBody>
+          <a:bodyPr wrap="square" lIns="0" tIns="0" rIns="0" bIns="0" rtlCol="0" anchor="ctr"/>
+          <a:lstStyle/>
+          <a:p>
+            <a:pPr algn="ctr" indent="0" marL="0">
+              <a:buNone/>
+            </a:pPr>
+            <a:r>
+              <a:rPr lang="en-US" sz="1300" b="1" dirty="0">
+                <a:solidFill>
+                  <a:srgbClr val="B1FF37"/>
+                </a:solidFill>
+                <a:latin typeface="Poppins" pitchFamily="34" charset="0"/>
+                <a:ea typeface="Poppins" pitchFamily="34" charset="-122"/>
+                <a:cs typeface="Poppins" pitchFamily="34" charset="-120"/>
+              </a:rPr>
+              <a:t>Autor</a:t>
+            </a:r>
+            <a:endParaRPr lang="en-US" sz="1300" dirty="0"/>
+          </a:p>
+        </p:txBody>
+      </p:sp>
+      <p:sp>
+        <p:nvSpPr>
+          <p:cNvPr id="27" name="Tabelle Zelle 4"/>
+          <p:cNvSpPr/>
+          <p:nvPr/>
+        </p:nvSpPr>
+        <p:spPr>
+          <a:xfrm>
+            <a:off x="9029700" y="685800"/>
+            <a:ext cx="742950" cy="361950"/>
+          </a:xfrm>
+          <a:prstGeom prst="rect">
+            <a:avLst/>
+          </a:prstGeom>
+          <a:solidFill>
+            <a:srgbClr val="B1FF37"/>
+          </a:solidFill>
+          <a:ln w="19050">
+            <a:solidFill>
+              <a:srgbClr val="B8D98A"/>
+            </a:solidFill>
+            <a:prstDash val="solid"/>
+          </a:ln>
+        </p:spPr>
+      </p:sp>
+      <p:sp>
+        <p:nvSpPr>
+          <p:cNvPr id="28" name="Tabelle Text 4"/>
+          <p:cNvSpPr txBox="1"/>
+          <p:nvPr/>
+        </p:nvSpPr>
+        <p:spPr>
+          <a:xfrm>
+            <a:off x="9029700" y="685800"/>
+            <a:ext cx="742950" cy="361950"/>
+          </a:xfrm>
+          <a:prstGeom prst="rect">
+            <a:avLst/>
+          </a:prstGeom>
+          <a:noFill/>
+          <a:ln/>
+        </p:spPr>
+        <p:txBody>
+          <a:bodyPr wrap="square" lIns="0" tIns="0" rIns="0" bIns="0" rtlCol="0" anchor="ctr"/>
+          <a:lstStyle/>
+          <a:p>
+            <a:pPr algn="ctr" indent="0" marL="0">
+              <a:buNone/>
+            </a:pPr>
+            <a:r>
+              <a:rPr lang="en-US" sz="1300" b="1" dirty="0">
+                <a:solidFill>
+                  <a:srgbClr val="12301A"/>
+                </a:solidFill>
+                <a:latin typeface="Poppins" pitchFamily="34" charset="0"/>
+                <a:ea typeface="Poppins" pitchFamily="34" charset="-122"/>
+                <a:cs typeface="Poppins" pitchFamily="34" charset="-120"/>
+              </a:rPr>
+              <a:t>1</a:t>
+            </a:r>
+            <a:endParaRPr lang="en-US" sz="1300" dirty="0"/>
+          </a:p>
+        </p:txBody>
+      </p:sp>
+      <p:sp>
+        <p:nvSpPr>
+          <p:cNvPr id="29" name="Tabelle Zelle 5"/>
+          <p:cNvSpPr/>
+          <p:nvPr/>
+        </p:nvSpPr>
+        <p:spPr>
+          <a:xfrm>
+            <a:off x="9772650" y="685800"/>
+            <a:ext cx="1066800" cy="361950"/>
+          </a:xfrm>
+          <a:prstGeom prst="rect">
+            <a:avLst/>
+          </a:prstGeom>
+          <a:solidFill>
+            <a:srgbClr val="FBFFF4"/>
+          </a:solidFill>
+          <a:ln w="19050">
+            <a:solidFill>
+              <a:srgbClr val="B8D98A"/>
+            </a:solidFill>
+            <a:prstDash val="solid"/>
+          </a:ln>
+        </p:spPr>
+      </p:sp>
+      <p:sp>
+        <p:nvSpPr>
+          <p:cNvPr id="30" name="Tabelle Text 5"/>
+          <p:cNvSpPr txBox="1"/>
+          <p:nvPr/>
+        </p:nvSpPr>
+        <p:spPr>
+          <a:xfrm>
+            <a:off x="9772650" y="685800"/>
+            <a:ext cx="1066800" cy="361950"/>
+          </a:xfrm>
+          <a:prstGeom prst="rect">
+            <a:avLst/>
+          </a:prstGeom>
+          <a:noFill/>
+          <a:ln/>
+        </p:spPr>
+        <p:txBody>
+          <a:bodyPr wrap="square" lIns="0" tIns="0" rIns="0" bIns="0" rtlCol="0" anchor="ctr"/>
+          <a:lstStyle/>
+          <a:p>
+            <a:pPr algn="ctr" indent="0" marL="0">
+              <a:buNone/>
+            </a:pPr>
+            <a:r>
+              <a:rPr lang="en-US" sz="1300" b="1" dirty="0">
+                <a:solidFill>
+                  <a:srgbClr val="12301A"/>
+                </a:solidFill>
+                <a:latin typeface="Poppins" pitchFamily="34" charset="0"/>
+                <a:ea typeface="Poppins" pitchFamily="34" charset="-122"/>
+                <a:cs typeface="Poppins" pitchFamily="34" charset="-120"/>
+              </a:rPr>
+              <a:t>…</a:t>
+            </a:r>
+            <a:endParaRPr lang="en-US" sz="1300" dirty="0"/>
+          </a:p>
+        </p:txBody>
+      </p:sp>
+      <p:sp>
+        <p:nvSpPr>
+          <p:cNvPr id="31" name="Tabelle Zelle 6"/>
+          <p:cNvSpPr/>
+          <p:nvPr/>
+        </p:nvSpPr>
+        <p:spPr>
+          <a:xfrm>
+            <a:off x="10839450" y="685800"/>
+            <a:ext cx="1066800" cy="361950"/>
+          </a:xfrm>
+          <a:prstGeom prst="rect">
+            <a:avLst/>
+          </a:prstGeom>
+          <a:solidFill>
+            <a:srgbClr val="FBFFF4"/>
+          </a:solidFill>
+          <a:ln w="19050">
+            <a:solidFill>
+              <a:srgbClr val="B8D98A"/>
+            </a:solidFill>
+            <a:prstDash val="solid"/>
+          </a:ln>
+        </p:spPr>
+      </p:sp>
+      <p:sp>
+        <p:nvSpPr>
+          <p:cNvPr id="32" name="Tabelle Text 6"/>
+          <p:cNvSpPr txBox="1"/>
+          <p:nvPr/>
+        </p:nvSpPr>
+        <p:spPr>
+          <a:xfrm>
+            <a:off x="10839450" y="685800"/>
+            <a:ext cx="1066800" cy="361950"/>
+          </a:xfrm>
+          <a:prstGeom prst="rect">
+            <a:avLst/>
+          </a:prstGeom>
+          <a:noFill/>
+          <a:ln/>
+        </p:spPr>
+        <p:txBody>
+          <a:bodyPr wrap="square" lIns="0" tIns="0" rIns="0" bIns="0" rtlCol="0" anchor="ctr"/>
+          <a:lstStyle/>
+          <a:p>
+            <a:pPr algn="ctr" indent="0" marL="0">
+              <a:buNone/>
+            </a:pPr>
+            <a:r>
+              <a:rPr lang="en-US" sz="1300" b="1" dirty="0">
+                <a:solidFill>
+                  <a:srgbClr val="12301A"/>
+                </a:solidFill>
+                <a:latin typeface="Poppins" pitchFamily="34" charset="0"/>
+                <a:ea typeface="Poppins" pitchFamily="34" charset="-122"/>
+                <a:cs typeface="Poppins" pitchFamily="34" charset="-120"/>
+              </a:rPr>
+              <a:t>…</a:t>
+            </a:r>
+            <a:endParaRPr lang="en-US" sz="1300" dirty="0"/>
+          </a:p>
+        </p:txBody>
+      </p:sp>
+      <p:sp>
+        <p:nvSpPr>
+          <p:cNvPr id="33" name="Tabelle Zelle 7"/>
+          <p:cNvSpPr/>
+          <p:nvPr/>
+        </p:nvSpPr>
+        <p:spPr>
+          <a:xfrm>
+            <a:off x="9029700" y="1047750"/>
+            <a:ext cx="742950" cy="361950"/>
+          </a:xfrm>
+          <a:prstGeom prst="rect">
+            <a:avLst/>
+          </a:prstGeom>
+          <a:solidFill>
+            <a:srgbClr val="FBFFF4"/>
+          </a:solidFill>
+          <a:ln w="19050">
+            <a:solidFill>
+              <a:srgbClr val="B8D98A"/>
+            </a:solidFill>
+            <a:prstDash val="solid"/>
+          </a:ln>
+        </p:spPr>
+      </p:sp>
+      <p:sp>
+        <p:nvSpPr>
+          <p:cNvPr id="34" name="Tabelle Text 7"/>
+          <p:cNvSpPr txBox="1"/>
+          <p:nvPr/>
+        </p:nvSpPr>
+        <p:spPr>
+          <a:xfrm>
+            <a:off x="9029700" y="1047750"/>
+            <a:ext cx="742950" cy="361950"/>
+          </a:xfrm>
+          <a:prstGeom prst="rect">
+            <a:avLst/>
+          </a:prstGeom>
+          <a:noFill/>
+          <a:ln/>
+        </p:spPr>
+        <p:txBody>
+          <a:bodyPr wrap="square" lIns="0" tIns="0" rIns="0" bIns="0" rtlCol="0" anchor="ctr"/>
+          <a:lstStyle/>
+          <a:p>
+            <a:pPr algn="ctr" indent="0" marL="0">
+              <a:buNone/>
+            </a:pPr>
+            <a:r>
+              <a:rPr lang="en-US" sz="1300" b="1" dirty="0">
+                <a:solidFill>
+                  <a:srgbClr val="12301A"/>
+                </a:solidFill>
+                <a:latin typeface="Poppins" pitchFamily="34" charset="0"/>
+                <a:ea typeface="Poppins" pitchFamily="34" charset="-122"/>
+                <a:cs typeface="Poppins" pitchFamily="34" charset="-120"/>
+              </a:rPr>
+              <a:t>2</a:t>
+            </a:r>
+            <a:endParaRPr lang="en-US" sz="1300" dirty="0"/>
+          </a:p>
+        </p:txBody>
+      </p:sp>
+      <p:sp>
+        <p:nvSpPr>
+          <p:cNvPr id="35" name="Tabelle Zelle 8"/>
+          <p:cNvSpPr/>
+          <p:nvPr/>
+        </p:nvSpPr>
+        <p:spPr>
+          <a:xfrm>
+            <a:off x="9772650" y="1047750"/>
+            <a:ext cx="1066800" cy="361950"/>
+          </a:xfrm>
+          <a:prstGeom prst="rect">
+            <a:avLst/>
+          </a:prstGeom>
+          <a:solidFill>
+            <a:srgbClr val="FBFFF4"/>
+          </a:solidFill>
+          <a:ln w="19050">
+            <a:solidFill>
+              <a:srgbClr val="B8D98A"/>
+            </a:solidFill>
+            <a:prstDash val="solid"/>
+          </a:ln>
+        </p:spPr>
+      </p:sp>
+      <p:sp>
+        <p:nvSpPr>
+          <p:cNvPr id="36" name="Tabelle Text 8"/>
+          <p:cNvSpPr txBox="1"/>
+          <p:nvPr/>
+        </p:nvSpPr>
+        <p:spPr>
+          <a:xfrm>
+            <a:off x="9772650" y="1047750"/>
+            <a:ext cx="1066800" cy="361950"/>
+          </a:xfrm>
+          <a:prstGeom prst="rect">
+            <a:avLst/>
+          </a:prstGeom>
+          <a:noFill/>
+          <a:ln/>
+        </p:spPr>
+        <p:txBody>
+          <a:bodyPr wrap="square" lIns="0" tIns="0" rIns="0" bIns="0" rtlCol="0" anchor="ctr"/>
+          <a:lstStyle/>
+          <a:p>
+            <a:pPr algn="ctr" indent="0" marL="0">
+              <a:buNone/>
+            </a:pPr>
+            <a:r>
+              <a:rPr lang="en-US" sz="1300" b="1" dirty="0">
+                <a:solidFill>
+                  <a:srgbClr val="12301A"/>
+                </a:solidFill>
+                <a:latin typeface="Poppins" pitchFamily="34" charset="0"/>
+                <a:ea typeface="Poppins" pitchFamily="34" charset="-122"/>
+                <a:cs typeface="Poppins" pitchFamily="34" charset="-120"/>
+              </a:rPr>
+              <a:t>…</a:t>
+            </a:r>
+            <a:endParaRPr lang="en-US" sz="1300" dirty="0"/>
+          </a:p>
+        </p:txBody>
+      </p:sp>
+      <p:sp>
+        <p:nvSpPr>
+          <p:cNvPr id="37" name="Tabelle Zelle 9"/>
+          <p:cNvSpPr/>
+          <p:nvPr/>
+        </p:nvSpPr>
+        <p:spPr>
+          <a:xfrm>
+            <a:off x="10839450" y="1047750"/>
+            <a:ext cx="1066800" cy="361950"/>
+          </a:xfrm>
+          <a:prstGeom prst="rect">
+            <a:avLst/>
+          </a:prstGeom>
+          <a:solidFill>
+            <a:srgbClr val="FBFFF4"/>
+          </a:solidFill>
+          <a:ln w="19050">
+            <a:solidFill>
+              <a:srgbClr val="B8D98A"/>
+            </a:solidFill>
+            <a:prstDash val="solid"/>
+          </a:ln>
+        </p:spPr>
+      </p:sp>
+      <p:sp>
+        <p:nvSpPr>
+          <p:cNvPr id="38" name="Tabelle Text 9"/>
+          <p:cNvSpPr txBox="1"/>
+          <p:nvPr/>
+        </p:nvSpPr>
+        <p:spPr>
+          <a:xfrm>
+            <a:off x="10839450" y="1047750"/>
+            <a:ext cx="1066800" cy="361950"/>
+          </a:xfrm>
+          <a:prstGeom prst="rect">
+            <a:avLst/>
+          </a:prstGeom>
+          <a:noFill/>
+          <a:ln/>
+        </p:spPr>
+        <p:txBody>
+          <a:bodyPr wrap="square" lIns="0" tIns="0" rIns="0" bIns="0" rtlCol="0" anchor="ctr"/>
+          <a:lstStyle/>
+          <a:p>
+            <a:pPr algn="ctr" indent="0" marL="0">
+              <a:buNone/>
+            </a:pPr>
+            <a:r>
+              <a:rPr lang="en-US" sz="1300" b="1" dirty="0">
+                <a:solidFill>
+                  <a:srgbClr val="12301A"/>
+                </a:solidFill>
+                <a:latin typeface="Poppins" pitchFamily="34" charset="0"/>
+                <a:ea typeface="Poppins" pitchFamily="34" charset="-122"/>
+                <a:cs typeface="Poppins" pitchFamily="34" charset="-120"/>
+              </a:rPr>
+              <a:t>…</a:t>
+            </a:r>
+            <a:endParaRPr lang="en-US" sz="1300" dirty="0"/>
+          </a:p>
+        </p:txBody>
       </p:sp>
     </p:spTree>
   </p:cSld>

</xml_diff>